<commit_message>
Set domain ykkn-youtube.com, Zoom/in-person option, 10/10 deadline
- LP/form/特商法/script/slide S37: consultation via Zoom or in person,
  special price deadline 2026-10-10 (5 days after seminar)
- Fix seminar weekday (10/5 is Monday)
- Concrete setup steps for domain purchase and Cloudflare Pages

Co-Authored-By: Claude Opus 5.5 <noreply@anthropic.com>
Claude-Session: https://claude.ai/code/session_013W5anzYXNxdrYCzkjjTgrP
</commit_message>
<xml_diff>
--- a/seminar-20261005/slides/YouTubeセミナー_v7.pptx
+++ b/seminar-20261005/slides/YouTubeセミナー_v7.pptx
@@ -2997,7 +2997,7 @@
           <a:p>
             <a:r>
               <a:rPr lang="en-US" dirty="0"/>
-              <a:t>今日は考え方中心。でも成功ライン・空いている場所・続けられるペースは一人ひとり全く違う。そこで参加者特典：あなたのチャンネルに合わせた個別相談。業種・目的を聞いて道筋づくりとペース設計を一緒に整理。集客・商品販売・収益化で戦い方が変わる。通常30,000円→本日参加の方は15,000円（希望者のみ）。終了後に私か塩谷会計事務所さんまで。その後、質疑応答へ。</a:t>
+              <a:t>今日は考え方中心。でも成功ライン・空いている場所・続けられるペースは一人ひとり全く違う。そこで参加者特典：あなたのチャンネルに合わせた個別相談。業種・目的を聞いて道筋づくりとペース設計を一緒に整理。集客・商品販売・収益化で戦い方が変わる。通常30,000円→本日参加の方は15,000円（30分・Zoom／対面どちらも可・希望者のみ・申込期限は10/10(土)まで）。終了後に私か塩谷会計事務所さんまで。その後、質疑応答へ。</a:t>
             </a:r>
             <a:endParaRPr lang="en-US" dirty="0"/>
           </a:p>
@@ -14616,6 +14616,10 @@
           </a:solidFill>
           <a:ln/>
         </p:spPr>
+        <p:txBody>
+          <a:bodyPr/>
+          <a:p/>
+        </p:txBody>
       </p:sp>
       <p:sp>
         <p:nvSpPr>
@@ -14678,8 +14682,8 @@
         </p:nvSpPr>
         <p:spPr>
           <a:xfrm>
-            <a:off x="822960" y="5212080"/>
-            <a:ext cx="10607040" cy="548640"/>
+            <a:off x="822960" y="5440680"/>
+            <a:ext cx="10607040" cy="914400"/>
           </a:xfrm>
           <a:prstGeom prst="rect">
             <a:avLst/>
@@ -14703,7 +14707,24 @@
                 <a:ea typeface="Meiryo" pitchFamily="34" charset="-122"/>
                 <a:cs typeface="Meiryo" pitchFamily="34" charset="-120"/>
               </a:rPr>
-              <a:t>業種・目的に合わせて、チャンネルの方向性・続けられるペース設計を一緒に整理します（希望者のみ）</a:t>
+              <a:t>業種・目的に合わせて、チャンネルの方向性・続けられるペース設計を一緒に整理します（30分／Zoom・対面どちらも可／希望者のみ）</a:t>
+            </a:r>
+            <a:endParaRPr lang="en-US" sz="2000" dirty="0"/>
+          </a:p>
+          <a:p>
+            <a:pPr indent="0" marL="0">
+              <a:buNone/>
+            </a:pPr>
+            <a:r>
+              <a:rPr lang="en-US" sz="2000" dirty="0" b="1">
+                <a:solidFill>
+                  <a:srgbClr val="FFFFFF"/>
+                </a:solidFill>
+                <a:latin typeface="Meiryo" pitchFamily="34" charset="0"/>
+                <a:ea typeface="Meiryo" pitchFamily="34" charset="-122"/>
+                <a:cs typeface="Meiryo" pitchFamily="34" charset="-120"/>
+              </a:rPr>
+              <a:t>お申し込み期限：10月10日（土）まで</a:t>
             </a:r>
             <a:endParaRPr lang="en-US" sz="2000" dirty="0"/>
           </a:p>

</xml_diff>

<commit_message>
Add LP QR code to slide S37 and script
Co-Authored-By: Claude Opus 5.5 <noreply@anthropic.com>
Claude-Session: https://claude.ai/code/session_013W5anzYXNxdrYCzkjjTgrP
</commit_message>
<xml_diff>
--- a/seminar-20261005/slides/YouTubeセミナー_v7.pptx
+++ b/seminar-20261005/slides/YouTubeセミナー_v7.pptx
@@ -14630,23 +14630,23 @@
         <p:spPr>
           <a:xfrm>
             <a:off x="1188720" y="3383280"/>
-            <a:ext cx="9875520" cy="1005840"/>
-          </a:xfrm>
-          <a:prstGeom prst="rect">
-            <a:avLst/>
-          </a:prstGeom>
-          <a:noFill/>
-          <a:ln/>
-        </p:spPr>
-        <p:txBody>
-          <a:bodyPr wrap="square" lIns="0" tIns="0" rIns="0" bIns="0" rtlCol="0" anchor="ctr"/>
-          <a:lstStyle/>
-          <a:p>
-            <a:pPr indent="0" marL="0">
-              <a:buNone/>
-            </a:pPr>
-            <a:r>
-              <a:rPr lang="en-US" sz="3000" strike="sngStrike" dirty="0">
+            <a:ext cx="8183879" cy="1005840"/>
+          </a:xfrm>
+          <a:prstGeom prst="rect">
+            <a:avLst/>
+          </a:prstGeom>
+          <a:noFill/>
+          <a:ln/>
+        </p:spPr>
+        <p:txBody>
+          <a:bodyPr wrap="square" lIns="0" tIns="0" rIns="0" bIns="0" rtlCol="0" anchor="ctr"/>
+          <a:lstStyle/>
+          <a:p>
+            <a:pPr indent="0" marL="0">
+              <a:buNone/>
+            </a:pPr>
+            <a:r>
+              <a:rPr lang="en-US" sz="2400" strike="sngStrike" dirty="0">
                 <a:solidFill>
                   <a:srgbClr val="7A6A00"/>
                 </a:solidFill>
@@ -14660,7 +14660,7 @@
               <a:buNone/>
             </a:pPr>
             <a:r>
-              <a:rPr lang="en-US" sz="4000" b="1" dirty="0">
+              <a:rPr lang="en-US" sz="3400" b="1" dirty="0">
                 <a:solidFill>
                   <a:srgbClr val="C40000"/>
                 </a:solidFill>
@@ -14727,6 +14727,64 @@
               <a:t>お申し込み期限：10月10日（土）まで</a:t>
             </a:r>
             <a:endParaRPr lang="en-US" sz="2000" dirty="0"/>
+          </a:p>
+        </p:txBody>
+      </p:sp>
+      <p:pic>
+        <p:nvPicPr>
+          <p:cNvPr id="7" name="Picture 6" descr="qr_lp.png"/>
+          <p:cNvPicPr>
+            <a:picLocks noChangeAspect="1"/>
+          </p:cNvPicPr>
+          <p:nvPr/>
+        </p:nvPicPr>
+        <p:blipFill>
+          <a:blip r:embed="rId3"/>
+          <a:stretch>
+            <a:fillRect/>
+          </a:stretch>
+        </p:blipFill>
+        <p:spPr>
+          <a:xfrm>
+            <a:off x="9555480" y="2944368"/>
+            <a:ext cx="1463040" cy="1463040"/>
+          </a:xfrm>
+          <a:prstGeom prst="rect">
+            <a:avLst/>
+          </a:prstGeom>
+        </p:spPr>
+      </p:pic>
+      <p:sp>
+        <p:nvSpPr>
+          <p:cNvPr id="8" name="TextBox 7"/>
+          <p:cNvSpPr txBox="1"/>
+          <p:nvPr/>
+        </p:nvSpPr>
+        <p:spPr>
+          <a:xfrm>
+            <a:off x="9098280" y="4443984"/>
+            <a:ext cx="2377440" cy="365760"/>
+          </a:xfrm>
+          <a:prstGeom prst="rect">
+            <a:avLst/>
+          </a:prstGeom>
+          <a:noFill/>
+        </p:spPr>
+        <p:txBody>
+          <a:bodyPr wrap="none" lIns="0" rIns="0" tIns="0" bIns="0">
+            <a:spAutoFit/>
+          </a:bodyPr>
+          <a:lstStyle/>
+          <a:p>
+            <a:pPr algn="ctr"/>
+            <a:r>
+              <a:rPr sz="1300" b="1">
+                <a:solidFill>
+                  <a:srgbClr val="C40000"/>
+                </a:solidFill>
+              </a:rPr>
+              <a:t>お申し込みはこちら</a:t>
+            </a:r>
           </a:p>
         </p:txBody>
       </p:sp>

</xml_diff>